<commit_message>
Show only founder names in the Who we are card
Co-Authored-By: Claude Opus 5.5 <noreply@anthropic.com>
Claude-Session: https://claude.ai/code/session_01CFjizt5zjDrPrNkUDYBzBn
</commit_message>
<xml_diff>
--- a/decks/david-samuel/Extol-x-David-Samuel-Advisory-Briefing.pptx
+++ b/decks/david-samuel/Extol-x-David-Samuel-Advisory-Briefing.pptx
@@ -124,26 +124,26 @@
   <p:extLst>
     <p:ext uri="{521415D9-36F7-43E2-AB2F-B90AF26B5E84}">
       <p14:sectionLst xmlns:p14="http://schemas.microsoft.com/office/powerpoint/2010/main">
-        <p14:section name="Opening" id="{95983ab8-08d8-6936-191b-33cf3b3ef835}">
+        <p14:section name="Opening" id="{1fa6126f-6388-3ef1-8f1b-1252e5377a04}">
           <p14:sldIdLst>
             <p14:sldId id="256"/>
             <p14:sldId id="257"/>
           </p14:sldIdLst>
         </p14:section>
-        <p14:section name="Who we are" id="{9627735b-b77b-d8da-dade-67f2eb245ffa}">
+        <p14:section name="Who we are" id="{998c28cf-ec9d-a400-30f2-316f6ad72fde}">
           <p14:sldIdLst>
             <p14:sldId id="258"/>
             <p14:sldId id="259"/>
             <p14:sldId id="260"/>
           </p14:sldIdLst>
         </p14:section>
-        <p14:section name="What we’ve done" id="{2d8bdf58-a2c5-8ffb-0ad8-3f2c6e70cabd}">
+        <p14:section name="What we’ve done" id="{91387f0a-82a2-b5f7-9096-2826636e78d2}">
           <p14:sldIdLst>
             <p14:sldId id="261"/>
             <p14:sldId id="262"/>
           </p14:sldIdLst>
         </p14:section>
-        <p14:section name="What we offer" id="{4d67d9aa-76ee-b9df-4adc-31b124fd0deb}">
+        <p14:section name="What we offer" id="{9decd1b6-142c-a46b-e91c-ef7bacd07c53}">
           <p14:sldIdLst>
             <p14:sldId id="263"/>
             <p14:sldId id="264"/>
@@ -152,7 +152,7 @@
             <p14:sldId id="267"/>
           </p14:sldIdLst>
         </p14:section>
-        <p14:section name="Your role" id="{bf3848b2-c3aa-4d11-6717-9ecfe95e7735}">
+        <p14:section name="Your role" id="{2c132a51-793f-ce43-4322-d40f4a5a1410}">
           <p14:sldIdLst>
             <p14:sldId id="268"/>
             <p14:sldId id="269"/>
@@ -161,7 +161,7 @@
             <p14:sldId id="272"/>
           </p14:sldIdLst>
         </p14:section>
-        <p14:section name="Close" id="{4b852219-598a-43a7-013d-bd82bbf80669}">
+        <p14:section name="Close" id="{45e165c0-f6ad-e8dd-7246-870487d8db0a}">
           <p14:sldIdLst>
             <p14:sldId id="273"/>
           </p14:sldIdLst>
@@ -9755,7 +9755,21 @@
                   <a:schemeClr val="tx2"/>
                 </a:solidFill>
               </a:rPr>
-              <a:t>Two founders: Dave runs strategy, Anshul runs delivery.</a:t>
+              <a:t>Devasya Dwivedi</a:t>
+            </a:r>
+            <a:endParaRPr lang="en-US" sz="1700" dirty="0"/>
+          </a:p>
+          <a:p>
+            <a:pPr indent="0" marL="0">
+              <a:buNone/>
+            </a:pPr>
+            <a:r>
+              <a:rPr lang="en-US" sz="1700" dirty="0">
+                <a:solidFill>
+                  <a:schemeClr val="tx2"/>
+                </a:solidFill>
+              </a:rPr>
+              <a:t>Anshul Mikita Prajapati</a:t>
             </a:r>
             <a:endParaRPr lang="en-US" sz="1700" dirty="0"/>
           </a:p>

</xml_diff>

<commit_message>
Set the David Samuel deck to Helvetica only
Theme heading and body fonts, explicit text runs, chart labels and the
master bullet font all use Helvetica. Shortened three labels that no
longer fit at Helvetica's wider set width.

Co-Authored-By: Claude Opus 5.5 <noreply@anthropic.com>
Claude-Session: https://claude.ai/code/session_01CFjizt5zjDrPrNkUDYBzBn
</commit_message>
<xml_diff>
--- a/decks/david-samuel/Extol-x-David-Samuel-Advisory-Briefing.pptx
+++ b/decks/david-samuel/Extol-x-David-Samuel-Advisory-Briefing.pptx
@@ -127,13 +127,13 @@
   <p:extLst>
     <p:ext uri="{521415D9-36F7-43E2-AB2F-B90AF26B5E84}">
       <p14:sectionLst xmlns:p14="http://schemas.microsoft.com/office/powerpoint/2010/main">
-        <p14:section name="Opening" id="{5db2995c-03b1-11f8-8156-ee1f65e99135}">
+        <p14:section name="Opening" id="{e236ed2f-6786-8aef-0e15-76bad0b29b06}">
           <p14:sldIdLst>
             <p14:sldId id="256"/>
             <p14:sldId id="257"/>
           </p14:sldIdLst>
         </p14:section>
-        <p14:section name="Who we are" id="{13d0b927-7329-895f-298f-6de459b1a5e4}">
+        <p14:section name="Who we are" id="{b28eef77-1e62-2510-d483-705aa26573d6}">
           <p14:sldIdLst>
             <p14:sldId id="258"/>
             <p14:sldId id="259"/>
@@ -141,13 +141,13 @@
             <p14:sldId id="261"/>
           </p14:sldIdLst>
         </p14:section>
-        <p14:section name="What we’ve done" id="{ac06cbdb-7617-67de-94c8-783002afefd3}">
+        <p14:section name="What we’ve done" id="{ea23935e-c9ef-1a40-01d9-5761f03dd643}">
           <p14:sldIdLst>
             <p14:sldId id="262"/>
             <p14:sldId id="263"/>
           </p14:sldIdLst>
         </p14:section>
-        <p14:section name="What we offer" id="{af620dbe-ac51-f7b3-673e-e5db64b0cacb}">
+        <p14:section name="What we offer" id="{bc390ed9-0f23-e185-f3ca-b310c1093ffd}">
           <p14:sldIdLst>
             <p14:sldId id="264"/>
             <p14:sldId id="265"/>
@@ -158,7 +158,7 @@
             <p14:sldId id="270"/>
           </p14:sldIdLst>
         </p14:section>
-        <p14:section name="Your role" id="{2bb4284b-2625-004a-1cfa-1f619ff3cdc4}">
+        <p14:section name="Your role" id="{ab637a48-e148-2340-8172-54ab2f735379}">
           <p14:sldIdLst>
             <p14:sldId id="271"/>
             <p14:sldId id="272"/>
@@ -167,7 +167,7 @@
             <p14:sldId id="275"/>
           </p14:sldIdLst>
         </p14:section>
-        <p14:section name="Close" id="{e41c9d0f-7737-ede6-c584-e86b60974fa8}">
+        <p14:section name="Close" id="{52b213e0-81ce-ac2e-ecb9-9a15dbeb7e3c}">
           <p14:sldIdLst>
             <p14:sldId id="276"/>
           </p14:sldIdLst>
@@ -399,7 +399,7 @@
                 <a:solidFill>
                   <a:srgbClr val="000000"/>
                 </a:solidFill>
-                <a:latin typeface="Arial"/>
+                <a:latin typeface="Helvetica"/>
               </a:defRPr>
             </a:pPr>
             <a:endParaRPr lang="en-US"/>
@@ -580,7 +580,7 @@
                     <a:solidFill>
                       <a:srgbClr val="000000"/>
                     </a:solidFill>
-                    <a:latin typeface="Arial"/>
+                    <a:latin typeface="Helvetica"/>
                   </a:defRPr>
                 </a:pPr>
               </a:p>
@@ -899,7 +899,7 @@
                 <a:solidFill>
                   <a:srgbClr val="000000"/>
                 </a:solidFill>
-                <a:latin typeface="Arial"/>
+                <a:latin typeface="Helvetica"/>
               </a:defRPr>
             </a:pPr>
             <a:endParaRPr lang="en-US"/>
@@ -1163,7 +1163,7 @@
                 <a:solidFill>
                   <a:srgbClr val="000000"/>
                 </a:solidFill>
-                <a:latin typeface="Arial"/>
+                <a:latin typeface="Helvetica"/>
               </a:defRPr>
             </a:pPr>
             <a:endParaRPr lang="en-US"/>
@@ -1471,7 +1471,7 @@
                 <a:solidFill>
                   <a:srgbClr val="000000"/>
                 </a:solidFill>
-                <a:latin typeface="Arial"/>
+                <a:latin typeface="Helvetica"/>
               </a:defRPr>
             </a:pPr>
             <a:endParaRPr lang="en-US"/>
@@ -3823,9 +3823,9 @@
                 <a:solidFill>
                   <a:schemeClr val="bg2"/>
                 </a:solidFill>
-                <a:latin typeface="Cambria" pitchFamily="34" charset="0"/>
-                <a:ea typeface="Cambria" pitchFamily="34" charset="-122"/>
-                <a:cs typeface="Cambria" pitchFamily="34" charset="-120"/>
+                <a:latin typeface="Helvetica" pitchFamily="34" charset="0"/>
+                <a:ea typeface="Helvetica" pitchFamily="34" charset="-122"/>
+                <a:cs typeface="Helvetica" pitchFamily="34" charset="-120"/>
               </a:defRPr>
             </a:lvl1pPr>
           </a:lstStyle>
@@ -3975,9 +3975,9 @@
                 <a:solidFill>
                   <a:schemeClr val="accent3"/>
                 </a:solidFill>
-                <a:latin typeface="Cambria" pitchFamily="34" charset="0"/>
-                <a:ea typeface="Cambria" pitchFamily="34" charset="-122"/>
-                <a:cs typeface="Cambria" pitchFamily="34" charset="-120"/>
+                <a:latin typeface="Helvetica" pitchFamily="34" charset="0"/>
+                <a:ea typeface="Helvetica" pitchFamily="34" charset="-122"/>
+                <a:cs typeface="Helvetica" pitchFamily="34" charset="-120"/>
               </a:defRPr>
             </a:lvl1pPr>
           </a:lstStyle>
@@ -4017,9 +4017,9 @@
                 <a:solidFill>
                   <a:schemeClr val="bg2"/>
                 </a:solidFill>
-                <a:latin typeface="Cambria" pitchFamily="34" charset="0"/>
-                <a:ea typeface="Cambria" pitchFamily="34" charset="-122"/>
-                <a:cs typeface="Cambria" pitchFamily="34" charset="-120"/>
+                <a:latin typeface="Helvetica" pitchFamily="34" charset="0"/>
+                <a:ea typeface="Helvetica" pitchFamily="34" charset="-122"/>
+                <a:cs typeface="Helvetica" pitchFamily="34" charset="-120"/>
               </a:defRPr>
             </a:lvl1pPr>
           </a:lstStyle>
@@ -4214,9 +4214,9 @@
                 <a:solidFill>
                   <a:schemeClr val="tx1"/>
                 </a:solidFill>
-                <a:latin typeface="Cambria" pitchFamily="34" charset="0"/>
-                <a:ea typeface="Cambria" pitchFamily="34" charset="-122"/>
-                <a:cs typeface="Cambria" pitchFamily="34" charset="-120"/>
+                <a:latin typeface="Helvetica" pitchFamily="34" charset="0"/>
+                <a:ea typeface="Helvetica" pitchFamily="34" charset="-122"/>
+                <a:cs typeface="Helvetica" pitchFamily="34" charset="-120"/>
               </a:defRPr>
             </a:lvl1pPr>
           </a:lstStyle>
@@ -4411,7 +4411,7 @@
         <a:spcBef>
           <a:spcPct val="20000"/>
         </a:spcBef>
-        <a:buFont typeface="Arial" pitchFamily="34" charset="0"/>
+        <a:buFont typeface="Helvetica" pitchFamily="34" charset="0"/>
         <a:buChar char="•"/>
         <a:defRPr sz="3200" kern="1200">
           <a:solidFill>
@@ -4426,7 +4426,7 @@
         <a:spcBef>
           <a:spcPct val="20000"/>
         </a:spcBef>
-        <a:buFont typeface="Arial" pitchFamily="34" charset="0"/>
+        <a:buFont typeface="Helvetica" pitchFamily="34" charset="0"/>
         <a:buChar char="–"/>
         <a:defRPr sz="2800" kern="1200">
           <a:solidFill>
@@ -4441,7 +4441,7 @@
         <a:spcBef>
           <a:spcPct val="20000"/>
         </a:spcBef>
-        <a:buFont typeface="Arial" pitchFamily="34" charset="0"/>
+        <a:buFont typeface="Helvetica" pitchFamily="34" charset="0"/>
         <a:buChar char="•"/>
         <a:defRPr sz="2400" kern="1200">
           <a:solidFill>
@@ -4456,7 +4456,7 @@
         <a:spcBef>
           <a:spcPct val="20000"/>
         </a:spcBef>
-        <a:buFont typeface="Arial" pitchFamily="34" charset="0"/>
+        <a:buFont typeface="Helvetica" pitchFamily="34" charset="0"/>
         <a:buChar char="–"/>
         <a:defRPr sz="2000" kern="1200">
           <a:solidFill>
@@ -4471,7 +4471,7 @@
         <a:spcBef>
           <a:spcPct val="20000"/>
         </a:spcBef>
-        <a:buFont typeface="Arial" pitchFamily="34" charset="0"/>
+        <a:buFont typeface="Helvetica" pitchFamily="34" charset="0"/>
         <a:buChar char="»"/>
         <a:defRPr sz="2000" kern="1200">
           <a:solidFill>
@@ -4486,7 +4486,7 @@
         <a:spcBef>
           <a:spcPct val="20000"/>
         </a:spcBef>
-        <a:buFont typeface="Arial" pitchFamily="34" charset="0"/>
+        <a:buFont typeface="Helvetica" pitchFamily="34" charset="0"/>
         <a:buChar char="•"/>
         <a:defRPr sz="2000" kern="1200">
           <a:solidFill>
@@ -4501,7 +4501,7 @@
         <a:spcBef>
           <a:spcPct val="20000"/>
         </a:spcBef>
-        <a:buFont typeface="Arial" pitchFamily="34" charset="0"/>
+        <a:buFont typeface="Helvetica" pitchFamily="34" charset="0"/>
         <a:buChar char="•"/>
         <a:defRPr sz="2000" kern="1200">
           <a:solidFill>
@@ -4516,7 +4516,7 @@
         <a:spcBef>
           <a:spcPct val="20000"/>
         </a:spcBef>
-        <a:buFont typeface="Arial" pitchFamily="34" charset="0"/>
+        <a:buFont typeface="Helvetica" pitchFamily="34" charset="0"/>
         <a:buChar char="•"/>
         <a:defRPr sz="2000" kern="1200">
           <a:solidFill>
@@ -4531,7 +4531,7 @@
         <a:spcBef>
           <a:spcPct val="20000"/>
         </a:spcBef>
-        <a:buFont typeface="Arial" pitchFamily="34" charset="0"/>
+        <a:buFont typeface="Helvetica" pitchFamily="34" charset="0"/>
         <a:buChar char="•"/>
         <a:defRPr sz="2000" kern="1200">
           <a:solidFill>
@@ -4728,9 +4728,9 @@
                 <a:solidFill>
                   <a:schemeClr val="bg2"/>
                 </a:solidFill>
-                <a:latin typeface="Cambria" pitchFamily="34" charset="0"/>
-                <a:ea typeface="Cambria" pitchFamily="34" charset="-122"/>
-                <a:cs typeface="Cambria" pitchFamily="34" charset="-120"/>
+                <a:latin typeface="Helvetica" pitchFamily="34" charset="0"/>
+                <a:ea typeface="Helvetica" pitchFamily="34" charset="-122"/>
+                <a:cs typeface="Helvetica" pitchFamily="34" charset="-120"/>
               </a:rPr>
               <a:t>Working together</a:t>
             </a:r>
@@ -4745,9 +4745,9 @@
                 <a:solidFill>
                   <a:schemeClr val="bg2"/>
                 </a:solidFill>
-                <a:latin typeface="Cambria" pitchFamily="34" charset="0"/>
-                <a:ea typeface="Cambria" pitchFamily="34" charset="-122"/>
-                <a:cs typeface="Cambria" pitchFamily="34" charset="-120"/>
+                <a:latin typeface="Helvetica" pitchFamily="34" charset="0"/>
+                <a:ea typeface="Helvetica" pitchFamily="34" charset="-122"/>
+                <a:cs typeface="Helvetica" pitchFamily="34" charset="-120"/>
               </a:rPr>
               <a:t>to win new clients</a:t>
             </a:r>
@@ -4925,9 +4925,9 @@
                 <a:solidFill>
                   <a:schemeClr val="tx1"/>
                 </a:solidFill>
-                <a:latin typeface="Cambria" pitchFamily="34" charset="0"/>
-                <a:ea typeface="Cambria" pitchFamily="34" charset="-122"/>
-                <a:cs typeface="Cambria" pitchFamily="34" charset="-120"/>
+                <a:latin typeface="Helvetica" pitchFamily="34" charset="0"/>
+                <a:ea typeface="Helvetica" pitchFamily="34" charset="-122"/>
+                <a:cs typeface="Helvetica" pitchFamily="34" charset="-120"/>
               </a:rPr>
               <a:t>A client gets four things</a:t>
             </a:r>
@@ -5040,11 +5040,11 @@
                 <a:solidFill>
                   <a:schemeClr val="tx1"/>
                 </a:solidFill>
-                <a:latin typeface="Cambria" pitchFamily="34" charset="0"/>
-                <a:ea typeface="Cambria" pitchFamily="34" charset="-122"/>
-                <a:cs typeface="Cambria" pitchFamily="34" charset="-120"/>
-              </a:rPr>
-              <a:t>1. Look credible</a:t>
+                <a:latin typeface="Helvetica" pitchFamily="34" charset="0"/>
+                <a:ea typeface="Helvetica" pitchFamily="34" charset="-122"/>
+                <a:cs typeface="Helvetica" pitchFamily="34" charset="-120"/>
+              </a:rPr>
+              <a:t>1. Credibility</a:t>
             </a:r>
             <a:endParaRPr lang="en-US" sz="2100" dirty="0"/>
           </a:p>
@@ -5227,11 +5227,11 @@
                 <a:solidFill>
                   <a:schemeClr val="tx1"/>
                 </a:solidFill>
-                <a:latin typeface="Cambria" pitchFamily="34" charset="0"/>
-                <a:ea typeface="Cambria" pitchFamily="34" charset="-122"/>
-                <a:cs typeface="Cambria" pitchFamily="34" charset="-120"/>
-              </a:rPr>
-              <a:t>2. Reach buyers</a:t>
+                <a:latin typeface="Helvetica" pitchFamily="34" charset="0"/>
+                <a:ea typeface="Helvetica" pitchFamily="34" charset="-122"/>
+                <a:cs typeface="Helvetica" pitchFamily="34" charset="-120"/>
+              </a:rPr>
+              <a:t>2. Outreach</a:t>
             </a:r>
             <a:endParaRPr lang="en-US" sz="2100" dirty="0"/>
           </a:p>
@@ -5414,11 +5414,11 @@
                 <a:solidFill>
                   <a:schemeClr val="tx1"/>
                 </a:solidFill>
-                <a:latin typeface="Cambria" pitchFamily="34" charset="0"/>
-                <a:ea typeface="Cambria" pitchFamily="34" charset="-122"/>
-                <a:cs typeface="Cambria" pitchFamily="34" charset="-120"/>
-              </a:rPr>
-              <a:t>3. Stay visible</a:t>
+                <a:latin typeface="Helvetica" pitchFamily="34" charset="0"/>
+                <a:ea typeface="Helvetica" pitchFamily="34" charset="-122"/>
+                <a:cs typeface="Helvetica" pitchFamily="34" charset="-120"/>
+              </a:rPr>
+              <a:t>3. Visibility</a:t>
             </a:r>
             <a:endParaRPr lang="en-US" sz="2100" dirty="0"/>
           </a:p>
@@ -5601,11 +5601,11 @@
                 <a:solidFill>
                   <a:schemeClr val="tx1"/>
                 </a:solidFill>
-                <a:latin typeface="Cambria" pitchFamily="34" charset="0"/>
-                <a:ea typeface="Cambria" pitchFamily="34" charset="-122"/>
-                <a:cs typeface="Cambria" pitchFamily="34" charset="-120"/>
-              </a:rPr>
-              <a:t>4. Track results</a:t>
+                <a:latin typeface="Helvetica" pitchFamily="34" charset="0"/>
+                <a:ea typeface="Helvetica" pitchFamily="34" charset="-122"/>
+                <a:cs typeface="Helvetica" pitchFamily="34" charset="-120"/>
+              </a:rPr>
+              <a:t>4. Results</a:t>
             </a:r>
             <a:endParaRPr lang="en-US" sz="2100" dirty="0"/>
           </a:p>
@@ -5822,11 +5822,11 @@
                 <a:solidFill>
                   <a:schemeClr val="tx1"/>
                 </a:solidFill>
-                <a:latin typeface="Cambria" pitchFamily="34" charset="0"/>
-                <a:ea typeface="Cambria" pitchFamily="34" charset="-122"/>
-                <a:cs typeface="Cambria" pitchFamily="34" charset="-120"/>
-              </a:rPr>
-              <a:t>How it works: the client spends about 2½ hours a week</a:t>
+                <a:latin typeface="Helvetica" pitchFamily="34" charset="0"/>
+                <a:ea typeface="Helvetica" pitchFamily="34" charset="-122"/>
+                <a:cs typeface="Helvetica" pitchFamily="34" charset="-120"/>
+              </a:rPr>
+              <a:t>How it works: 2½ hours a week from the client</a:t>
             </a:r>
             <a:endParaRPr lang="en-US" sz="3400" dirty="0"/>
           </a:p>
@@ -6674,9 +6674,9 @@
                 <a:solidFill>
                   <a:schemeClr val="tx1"/>
                 </a:solidFill>
-                <a:latin typeface="Cambria" pitchFamily="34" charset="0"/>
-                <a:ea typeface="Cambria" pitchFamily="34" charset="-122"/>
-                <a:cs typeface="Cambria" pitchFamily="34" charset="-120"/>
+                <a:latin typeface="Helvetica" pitchFamily="34" charset="0"/>
+                <a:ea typeface="Helvetica" pitchFamily="34" charset="-122"/>
+                <a:cs typeface="Helvetica" pitchFamily="34" charset="-120"/>
               </a:rPr>
               <a:t>What we expect it to produce each month</a:t>
             </a:r>
@@ -6875,9 +6875,9 @@
                 <a:solidFill>
                   <a:schemeClr val="tx1"/>
                 </a:solidFill>
-                <a:latin typeface="Cambria" pitchFamily="34" charset="0"/>
-                <a:ea typeface="Cambria" pitchFamily="34" charset="-122"/>
-                <a:cs typeface="Cambria" pitchFamily="34" charset="-120"/>
+                <a:latin typeface="Helvetica" pitchFamily="34" charset="0"/>
+                <a:ea typeface="Helvetica" pitchFamily="34" charset="-122"/>
+                <a:cs typeface="Helvetica" pitchFamily="34" charset="-120"/>
               </a:rPr>
               <a:t>Leads should build up month by month</a:t>
             </a:r>
@@ -6993,9 +6993,9 @@
                 <a:solidFill>
                   <a:schemeClr val="accent4"/>
                 </a:solidFill>
-                <a:latin typeface="Cambria" pitchFamily="34" charset="0"/>
-                <a:ea typeface="Cambria" pitchFamily="34" charset="-122"/>
-                <a:cs typeface="Cambria" pitchFamily="34" charset="-120"/>
+                <a:latin typeface="Helvetica" pitchFamily="34" charset="0"/>
+                <a:ea typeface="Helvetica" pitchFamily="34" charset="-122"/>
+                <a:cs typeface="Helvetica" pitchFamily="34" charset="-120"/>
               </a:rPr>
               <a:t>100</a:t>
             </a:r>
@@ -7068,9 +7068,9 @@
                 <a:solidFill>
                   <a:schemeClr val="accent4"/>
                 </a:solidFill>
-                <a:latin typeface="Cambria" pitchFamily="34" charset="0"/>
-                <a:ea typeface="Cambria" pitchFamily="34" charset="-122"/>
-                <a:cs typeface="Cambria" pitchFamily="34" charset="-120"/>
+                <a:latin typeface="Helvetica" pitchFamily="34" charset="0"/>
+                <a:ea typeface="Helvetica" pitchFamily="34" charset="-122"/>
+                <a:cs typeface="Helvetica" pitchFamily="34" charset="-120"/>
               </a:rPr>
               <a:t>10</a:t>
             </a:r>
@@ -7143,9 +7143,9 @@
                 <a:solidFill>
                   <a:schemeClr val="accent4"/>
                 </a:solidFill>
-                <a:latin typeface="Cambria" pitchFamily="34" charset="0"/>
-                <a:ea typeface="Cambria" pitchFamily="34" charset="-122"/>
-                <a:cs typeface="Cambria" pitchFamily="34" charset="-120"/>
+                <a:latin typeface="Helvetica" pitchFamily="34" charset="0"/>
+                <a:ea typeface="Helvetica" pitchFamily="34" charset="-122"/>
+                <a:cs typeface="Helvetica" pitchFamily="34" charset="-120"/>
               </a:rPr>
               <a:t>2–3</a:t>
             </a:r>
@@ -7364,9 +7364,9 @@
                 <a:solidFill>
                   <a:schemeClr val="tx1"/>
                 </a:solidFill>
-                <a:latin typeface="Cambria" pitchFamily="34" charset="0"/>
-                <a:ea typeface="Cambria" pitchFamily="34" charset="-122"/>
-                <a:cs typeface="Cambria" pitchFamily="34" charset="-120"/>
+                <a:latin typeface="Helvetica" pitchFamily="34" charset="0"/>
+                <a:ea typeface="Helvetica" pitchFamily="34" charset="-122"/>
+                <a:cs typeface="Helvetica" pitchFamily="34" charset="-120"/>
               </a:rPr>
               <a:t>What it costs: one monthly fee, every tool included</a:t>
             </a:r>
@@ -7466,9 +7466,9 @@
                 <a:solidFill>
                   <a:schemeClr val="accent1"/>
                 </a:solidFill>
-                <a:latin typeface="Cambria" pitchFamily="34" charset="0"/>
-                <a:ea typeface="Cambria" pitchFamily="34" charset="-122"/>
-                <a:cs typeface="Cambria" pitchFamily="34" charset="-120"/>
+                <a:latin typeface="Helvetica" pitchFamily="34" charset="0"/>
+                <a:ea typeface="Helvetica" pitchFamily="34" charset="-122"/>
+                <a:cs typeface="Helvetica" pitchFamily="34" charset="-120"/>
               </a:rPr>
               <a:t>£1,500</a:t>
             </a:r>
@@ -7604,9 +7604,9 @@
                 <a:solidFill>
                   <a:schemeClr val="accent1"/>
                 </a:solidFill>
-                <a:latin typeface="Cambria" pitchFamily="34" charset="0"/>
-                <a:ea typeface="Cambria" pitchFamily="34" charset="-122"/>
-                <a:cs typeface="Cambria" pitchFamily="34" charset="-120"/>
+                <a:latin typeface="Helvetica" pitchFamily="34" charset="0"/>
+                <a:ea typeface="Helvetica" pitchFamily="34" charset="-122"/>
+                <a:cs typeface="Helvetica" pitchFamily="34" charset="-120"/>
               </a:rPr>
               <a:t>£1,200</a:t>
             </a:r>
@@ -7742,9 +7742,9 @@
                 <a:solidFill>
                   <a:schemeClr val="bg2"/>
                 </a:solidFill>
-                <a:latin typeface="Cambria" pitchFamily="34" charset="0"/>
-                <a:ea typeface="Cambria" pitchFamily="34" charset="-122"/>
-                <a:cs typeface="Cambria" pitchFamily="34" charset="-120"/>
+                <a:latin typeface="Helvetica" pitchFamily="34" charset="0"/>
+                <a:ea typeface="Helvetica" pitchFamily="34" charset="-122"/>
+                <a:cs typeface="Helvetica" pitchFamily="34" charset="-120"/>
               </a:rPr>
               <a:t>£2,500</a:t>
             </a:r>
@@ -8012,9 +8012,9 @@
                 <a:solidFill>
                   <a:schemeClr val="tx1"/>
                 </a:solidFill>
-                <a:latin typeface="Cambria" pitchFamily="34" charset="0"/>
-                <a:ea typeface="Cambria" pitchFamily="34" charset="-122"/>
-                <a:cs typeface="Cambria" pitchFamily="34" charset="-120"/>
+                <a:latin typeface="Helvetica" pitchFamily="34" charset="0"/>
+                <a:ea typeface="Helvetica" pitchFamily="34" charset="-122"/>
+                <a:cs typeface="Helvetica" pitchFamily="34" charset="-120"/>
               </a:rPr>
               <a:t>One client win can pay for the whole year</a:t>
             </a:r>
@@ -8130,9 +8130,9 @@
                 <a:solidFill>
                   <a:schemeClr val="accent4"/>
                 </a:solidFill>
-                <a:latin typeface="Cambria" pitchFamily="34" charset="0"/>
-                <a:ea typeface="Cambria" pitchFamily="34" charset="-122"/>
-                <a:cs typeface="Cambria" pitchFamily="34" charset="-120"/>
+                <a:latin typeface="Helvetica" pitchFamily="34" charset="0"/>
+                <a:ea typeface="Helvetica" pitchFamily="34" charset="-122"/>
+                <a:cs typeface="Helvetica" pitchFamily="34" charset="-120"/>
               </a:rPr>
               <a:t>0.9×</a:t>
             </a:r>
@@ -8205,9 +8205,9 @@
                 <a:solidFill>
                   <a:schemeClr val="accent4"/>
                 </a:solidFill>
-                <a:latin typeface="Cambria" pitchFamily="34" charset="0"/>
-                <a:ea typeface="Cambria" pitchFamily="34" charset="-122"/>
-                <a:cs typeface="Cambria" pitchFamily="34" charset="-120"/>
+                <a:latin typeface="Helvetica" pitchFamily="34" charset="0"/>
+                <a:ea typeface="Helvetica" pitchFamily="34" charset="-122"/>
+                <a:cs typeface="Helvetica" pitchFamily="34" charset="-120"/>
               </a:rPr>
               <a:t>2.8×</a:t>
             </a:r>
@@ -8280,9 +8280,9 @@
                 <a:solidFill>
                   <a:schemeClr val="accent4"/>
                 </a:solidFill>
-                <a:latin typeface="Cambria" pitchFamily="34" charset="0"/>
-                <a:ea typeface="Cambria" pitchFamily="34" charset="-122"/>
-                <a:cs typeface="Cambria" pitchFamily="34" charset="-120"/>
+                <a:latin typeface="Helvetica" pitchFamily="34" charset="0"/>
+                <a:ea typeface="Helvetica" pitchFamily="34" charset="-122"/>
+                <a:cs typeface="Helvetica" pitchFamily="34" charset="-120"/>
               </a:rPr>
               <a:t>9.5×</a:t>
             </a:r>
@@ -8463,9 +8463,9 @@
                 <a:solidFill>
                   <a:schemeClr val="accent3"/>
                 </a:solidFill>
-                <a:latin typeface="Cambria" pitchFamily="34" charset="0"/>
-                <a:ea typeface="Cambria" pitchFamily="34" charset="-122"/>
-                <a:cs typeface="Cambria" pitchFamily="34" charset="-120"/>
+                <a:latin typeface="Helvetica" pitchFamily="34" charset="0"/>
+                <a:ea typeface="Helvetica" pitchFamily="34" charset="-122"/>
+                <a:cs typeface="Helvetica" pitchFamily="34" charset="-120"/>
               </a:rPr>
               <a:t>04</a:t>
             </a:r>
@@ -8504,9 +8504,9 @@
                 <a:solidFill>
                   <a:schemeClr val="bg2"/>
                 </a:solidFill>
-                <a:latin typeface="Cambria" pitchFamily="34" charset="0"/>
-                <a:ea typeface="Cambria" pitchFamily="34" charset="-122"/>
-                <a:cs typeface="Cambria" pitchFamily="34" charset="-120"/>
+                <a:latin typeface="Helvetica" pitchFamily="34" charset="0"/>
+                <a:ea typeface="Helvetica" pitchFamily="34" charset="-122"/>
+                <a:cs typeface="Helvetica" pitchFamily="34" charset="-120"/>
               </a:rPr>
               <a:t>Your role</a:t>
             </a:r>
@@ -8691,9 +8691,9 @@
                 <a:solidFill>
                   <a:schemeClr val="tx1"/>
                 </a:solidFill>
-                <a:latin typeface="Cambria" pitchFamily="34" charset="0"/>
-                <a:ea typeface="Cambria" pitchFamily="34" charset="-122"/>
-                <a:cs typeface="Cambria" pitchFamily="34" charset="-120"/>
+                <a:latin typeface="Helvetica" pitchFamily="34" charset="0"/>
+                <a:ea typeface="Helvetica" pitchFamily="34" charset="-122"/>
+                <a:cs typeface="Helvetica" pitchFamily="34" charset="-120"/>
               </a:rPr>
               <a:t>Three ways you can help us grow</a:t>
             </a:r>
@@ -8806,9 +8806,9 @@
                 <a:solidFill>
                   <a:schemeClr val="tx1"/>
                 </a:solidFill>
-                <a:latin typeface="Cambria" pitchFamily="34" charset="0"/>
-                <a:ea typeface="Cambria" pitchFamily="34" charset="-122"/>
-                <a:cs typeface="Cambria" pitchFamily="34" charset="-120"/>
+                <a:latin typeface="Helvetica" pitchFamily="34" charset="0"/>
+                <a:ea typeface="Helvetica" pitchFamily="34" charset="-122"/>
+                <a:cs typeface="Helvetica" pitchFamily="34" charset="-120"/>
               </a:rPr>
               <a:t>Advise</a:t>
             </a:r>
@@ -8957,9 +8957,9 @@
                 <a:solidFill>
                   <a:schemeClr val="tx1"/>
                 </a:solidFill>
-                <a:latin typeface="Cambria" pitchFamily="34" charset="0"/>
-                <a:ea typeface="Cambria" pitchFamily="34" charset="-122"/>
-                <a:cs typeface="Cambria" pitchFamily="34" charset="-120"/>
+                <a:latin typeface="Helvetica" pitchFamily="34" charset="0"/>
+                <a:ea typeface="Helvetica" pitchFamily="34" charset="-122"/>
+                <a:cs typeface="Helvetica" pitchFamily="34" charset="-120"/>
               </a:rPr>
               <a:t>Guide</a:t>
             </a:r>
@@ -9108,9 +9108,9 @@
                 <a:solidFill>
                   <a:schemeClr val="bg2"/>
                 </a:solidFill>
-                <a:latin typeface="Cambria" pitchFamily="34" charset="0"/>
-                <a:ea typeface="Cambria" pitchFamily="34" charset="-122"/>
-                <a:cs typeface="Cambria" pitchFamily="34" charset="-120"/>
+                <a:latin typeface="Helvetica" pitchFamily="34" charset="0"/>
+                <a:ea typeface="Helvetica" pitchFamily="34" charset="-122"/>
+                <a:cs typeface="Helvetica" pitchFamily="34" charset="-120"/>
               </a:rPr>
               <a:t>Introduce</a:t>
             </a:r>
@@ -9293,9 +9293,9 @@
                 <a:solidFill>
                   <a:schemeClr val="tx1"/>
                 </a:solidFill>
-                <a:latin typeface="Cambria" pitchFamily="34" charset="0"/>
-                <a:ea typeface="Cambria" pitchFamily="34" charset="-122"/>
-                <a:cs typeface="Cambria" pitchFamily="34" charset="-120"/>
+                <a:latin typeface="Helvetica" pitchFamily="34" charset="0"/>
+                <a:ea typeface="Helvetica" pitchFamily="34" charset="-122"/>
+                <a:cs typeface="Helvetica" pitchFamily="34" charset="-120"/>
               </a:rPr>
               <a:t>Where your experience matters most</a:t>
             </a:r>
@@ -9359,9 +9359,9 @@
                 <a:solidFill>
                   <a:schemeClr val="tx1"/>
                 </a:solidFill>
-                <a:latin typeface="Cambria" pitchFamily="34" charset="0"/>
-                <a:ea typeface="Cambria" pitchFamily="34" charset="-122"/>
-                <a:cs typeface="Cambria" pitchFamily="34" charset="-120"/>
+                <a:latin typeface="Helvetica" pitchFamily="34" charset="0"/>
+                <a:ea typeface="Helvetica" pitchFamily="34" charset="-122"/>
+                <a:cs typeface="Helvetica" pitchFamily="34" charset="-120"/>
               </a:rPr>
               <a:t>Proof</a:t>
             </a:r>
@@ -9399,7 +9399,7 @@
                   <a:schemeClr val="tx2"/>
                 </a:solidFill>
               </a:rPr>
-              <a:t>We don’t yet have a case study with hard numbers.</a:t>
+              <a:t>No case study with hard numbers yet.</a:t>
             </a:r>
             <a:endParaRPr lang="en-US" sz="1700" dirty="0"/>
           </a:p>
@@ -9497,9 +9497,9 @@
                 <a:solidFill>
                   <a:schemeClr val="tx1"/>
                 </a:solidFill>
-                <a:latin typeface="Cambria" pitchFamily="34" charset="0"/>
-                <a:ea typeface="Cambria" pitchFamily="34" charset="-122"/>
-                <a:cs typeface="Cambria" pitchFamily="34" charset="-120"/>
+                <a:latin typeface="Helvetica" pitchFamily="34" charset="0"/>
+                <a:ea typeface="Helvetica" pitchFamily="34" charset="-122"/>
+                <a:cs typeface="Helvetica" pitchFamily="34" charset="-120"/>
               </a:rPr>
               <a:t>Focus</a:t>
             </a:r>
@@ -9635,9 +9635,9 @@
                 <a:solidFill>
                   <a:schemeClr val="tx1"/>
                 </a:solidFill>
-                <a:latin typeface="Cambria" pitchFamily="34" charset="0"/>
-                <a:ea typeface="Cambria" pitchFamily="34" charset="-122"/>
-                <a:cs typeface="Cambria" pitchFamily="34" charset="-120"/>
+                <a:latin typeface="Helvetica" pitchFamily="34" charset="0"/>
+                <a:ea typeface="Helvetica" pitchFamily="34" charset="-122"/>
+                <a:cs typeface="Helvetica" pitchFamily="34" charset="-120"/>
               </a:rPr>
               <a:t>Pricing</a:t>
             </a:r>
@@ -9773,9 +9773,9 @@
                 <a:solidFill>
                   <a:schemeClr val="tx1"/>
                 </a:solidFill>
-                <a:latin typeface="Cambria" pitchFamily="34" charset="0"/>
-                <a:ea typeface="Cambria" pitchFamily="34" charset="-122"/>
-                <a:cs typeface="Cambria" pitchFamily="34" charset="-120"/>
+                <a:latin typeface="Helvetica" pitchFamily="34" charset="0"/>
+                <a:ea typeface="Helvetica" pitchFamily="34" charset="-122"/>
+                <a:cs typeface="Helvetica" pitchFamily="34" charset="-120"/>
               </a:rPr>
               <a:t>Growth</a:t>
             </a:r>
@@ -9994,9 +9994,9 @@
                 <a:solidFill>
                   <a:schemeClr val="tx1"/>
                 </a:solidFill>
-                <a:latin typeface="Cambria" pitchFamily="34" charset="0"/>
-                <a:ea typeface="Cambria" pitchFamily="34" charset="-122"/>
-                <a:cs typeface="Cambria" pitchFamily="34" charset="-120"/>
+                <a:latin typeface="Helvetica" pitchFamily="34" charset="0"/>
+                <a:ea typeface="Helvetica" pitchFamily="34" charset="-122"/>
+                <a:cs typeface="Helvetica" pitchFamily="34" charset="-120"/>
               </a:rPr>
               <a:t>How we could work together: three options</a:t>
             </a:r>
@@ -10145,9 +10145,9 @@
                 <a:solidFill>
                   <a:schemeClr val="bg2"/>
                 </a:solidFill>
-                <a:latin typeface="Cambria" pitchFamily="34" charset="0"/>
-                <a:ea typeface="Cambria" pitchFamily="34" charset="-122"/>
-                <a:cs typeface="Cambria" pitchFamily="34" charset="-120"/>
+                <a:latin typeface="Helvetica" pitchFamily="34" charset="0"/>
+                <a:ea typeface="Helvetica" pitchFamily="34" charset="-122"/>
+                <a:cs typeface="Helvetica" pitchFamily="34" charset="-120"/>
               </a:rPr>
               <a:t>A. Referral partner</a:t>
             </a:r>
@@ -10296,9 +10296,9 @@
                 <a:solidFill>
                   <a:schemeClr val="tx1"/>
                 </a:solidFill>
-                <a:latin typeface="Cambria" pitchFamily="34" charset="0"/>
-                <a:ea typeface="Cambria" pitchFamily="34" charset="-122"/>
-                <a:cs typeface="Cambria" pitchFamily="34" charset="-120"/>
+                <a:latin typeface="Helvetica" pitchFamily="34" charset="0"/>
+                <a:ea typeface="Helvetica" pitchFamily="34" charset="-122"/>
+                <a:cs typeface="Helvetica" pitchFamily="34" charset="-120"/>
               </a:rPr>
               <a:t>B. Advisor</a:t>
             </a:r>
@@ -10447,9 +10447,9 @@
                 <a:solidFill>
                   <a:schemeClr val="tx1"/>
                 </a:solidFill>
-                <a:latin typeface="Cambria" pitchFamily="34" charset="0"/>
-                <a:ea typeface="Cambria" pitchFamily="34" charset="-122"/>
-                <a:cs typeface="Cambria" pitchFamily="34" charset="-120"/>
+                <a:latin typeface="Helvetica" pitchFamily="34" charset="0"/>
+                <a:ea typeface="Helvetica" pitchFamily="34" charset="-122"/>
+                <a:cs typeface="Helvetica" pitchFamily="34" charset="-120"/>
               </a:rPr>
               <a:t>C. Strategic advisor</a:t>
             </a:r>
@@ -10668,9 +10668,9 @@
                 <a:solidFill>
                   <a:schemeClr val="tx1"/>
                 </a:solidFill>
-                <a:latin typeface="Cambria" pitchFamily="34" charset="0"/>
-                <a:ea typeface="Cambria" pitchFamily="34" charset="-122"/>
-                <a:cs typeface="Cambria" pitchFamily="34" charset="-120"/>
+                <a:latin typeface="Helvetica" pitchFamily="34" charset="0"/>
+                <a:ea typeface="Helvetica" pitchFamily="34" charset="-122"/>
+                <a:cs typeface="Helvetica" pitchFamily="34" charset="-120"/>
               </a:rPr>
               <a:t>Four questions, answered in order</a:t>
             </a:r>
@@ -10732,9 +10732,9 @@
                 <a:solidFill>
                   <a:schemeClr val="bg1"/>
                 </a:solidFill>
-                <a:latin typeface="Cambria" pitchFamily="34" charset="0"/>
-                <a:ea typeface="Cambria" pitchFamily="34" charset="-122"/>
-                <a:cs typeface="Cambria" pitchFamily="34" charset="-120"/>
+                <a:latin typeface="Helvetica" pitchFamily="34" charset="0"/>
+                <a:ea typeface="Helvetica" pitchFamily="34" charset="-122"/>
+                <a:cs typeface="Helvetica" pitchFamily="34" charset="-120"/>
               </a:rPr>
               <a:t>1</a:t>
             </a:r>
@@ -10771,9 +10771,9 @@
                 <a:solidFill>
                   <a:schemeClr val="tx1"/>
                 </a:solidFill>
-                <a:latin typeface="Cambria" pitchFamily="34" charset="0"/>
-                <a:ea typeface="Cambria" pitchFamily="34" charset="-122"/>
-                <a:cs typeface="Cambria" pitchFamily="34" charset="-120"/>
+                <a:latin typeface="Helvetica" pitchFamily="34" charset="0"/>
+                <a:ea typeface="Helvetica" pitchFamily="34" charset="-122"/>
+                <a:cs typeface="Helvetica" pitchFamily="34" charset="-120"/>
               </a:rPr>
               <a:t>Who we are</a:t>
             </a:r>
@@ -10871,9 +10871,9 @@
                 <a:solidFill>
                   <a:schemeClr val="bg1"/>
                 </a:solidFill>
-                <a:latin typeface="Cambria" pitchFamily="34" charset="0"/>
-                <a:ea typeface="Cambria" pitchFamily="34" charset="-122"/>
-                <a:cs typeface="Cambria" pitchFamily="34" charset="-120"/>
+                <a:latin typeface="Helvetica" pitchFamily="34" charset="0"/>
+                <a:ea typeface="Helvetica" pitchFamily="34" charset="-122"/>
+                <a:cs typeface="Helvetica" pitchFamily="34" charset="-120"/>
               </a:rPr>
               <a:t>2</a:t>
             </a:r>
@@ -10910,9 +10910,9 @@
                 <a:solidFill>
                   <a:schemeClr val="tx1"/>
                 </a:solidFill>
-                <a:latin typeface="Cambria" pitchFamily="34" charset="0"/>
-                <a:ea typeface="Cambria" pitchFamily="34" charset="-122"/>
-                <a:cs typeface="Cambria" pitchFamily="34" charset="-120"/>
+                <a:latin typeface="Helvetica" pitchFamily="34" charset="0"/>
+                <a:ea typeface="Helvetica" pitchFamily="34" charset="-122"/>
+                <a:cs typeface="Helvetica" pitchFamily="34" charset="-120"/>
               </a:rPr>
               <a:t>What we’ve done</a:t>
             </a:r>
@@ -11010,9 +11010,9 @@
                 <a:solidFill>
                   <a:schemeClr val="bg1"/>
                 </a:solidFill>
-                <a:latin typeface="Cambria" pitchFamily="34" charset="0"/>
-                <a:ea typeface="Cambria" pitchFamily="34" charset="-122"/>
-                <a:cs typeface="Cambria" pitchFamily="34" charset="-120"/>
+                <a:latin typeface="Helvetica" pitchFamily="34" charset="0"/>
+                <a:ea typeface="Helvetica" pitchFamily="34" charset="-122"/>
+                <a:cs typeface="Helvetica" pitchFamily="34" charset="-120"/>
               </a:rPr>
               <a:t>3</a:t>
             </a:r>
@@ -11049,9 +11049,9 @@
                 <a:solidFill>
                   <a:schemeClr val="tx1"/>
                 </a:solidFill>
-                <a:latin typeface="Cambria" pitchFamily="34" charset="0"/>
-                <a:ea typeface="Cambria" pitchFamily="34" charset="-122"/>
-                <a:cs typeface="Cambria" pitchFamily="34" charset="-120"/>
+                <a:latin typeface="Helvetica" pitchFamily="34" charset="0"/>
+                <a:ea typeface="Helvetica" pitchFamily="34" charset="-122"/>
+                <a:cs typeface="Helvetica" pitchFamily="34" charset="-120"/>
               </a:rPr>
               <a:t>What we offer</a:t>
             </a:r>
@@ -11149,9 +11149,9 @@
                 <a:solidFill>
                   <a:schemeClr val="bg1"/>
                 </a:solidFill>
-                <a:latin typeface="Cambria" pitchFamily="34" charset="0"/>
-                <a:ea typeface="Cambria" pitchFamily="34" charset="-122"/>
-                <a:cs typeface="Cambria" pitchFamily="34" charset="-120"/>
+                <a:latin typeface="Helvetica" pitchFamily="34" charset="0"/>
+                <a:ea typeface="Helvetica" pitchFamily="34" charset="-122"/>
+                <a:cs typeface="Helvetica" pitchFamily="34" charset="-120"/>
               </a:rPr>
               <a:t>4</a:t>
             </a:r>
@@ -11188,9 +11188,9 @@
                 <a:solidFill>
                   <a:schemeClr val="tx1"/>
                 </a:solidFill>
-                <a:latin typeface="Cambria" pitchFamily="34" charset="0"/>
-                <a:ea typeface="Cambria" pitchFamily="34" charset="-122"/>
-                <a:cs typeface="Cambria" pitchFamily="34" charset="-120"/>
+                <a:latin typeface="Helvetica" pitchFamily="34" charset="0"/>
+                <a:ea typeface="Helvetica" pitchFamily="34" charset="-122"/>
+                <a:cs typeface="Helvetica" pitchFamily="34" charset="-120"/>
               </a:rPr>
               <a:t>Your role</a:t>
             </a:r>
@@ -11373,9 +11373,9 @@
                 <a:solidFill>
                   <a:schemeClr val="tx1"/>
                 </a:solidFill>
-                <a:latin typeface="Cambria" pitchFamily="34" charset="0"/>
-                <a:ea typeface="Cambria" pitchFamily="34" charset="-122"/>
-                <a:cs typeface="Cambria" pitchFamily="34" charset="-120"/>
+                <a:latin typeface="Helvetica" pitchFamily="34" charset="0"/>
+                <a:ea typeface="Helvetica" pitchFamily="34" charset="-122"/>
+                <a:cs typeface="Helvetica" pitchFamily="34" charset="-120"/>
               </a:rPr>
               <a:t>The first 90 days together</a:t>
             </a:r>
@@ -11496,9 +11496,9 @@
                 <a:solidFill>
                   <a:schemeClr val="tx1"/>
                 </a:solidFill>
-                <a:latin typeface="Cambria" pitchFamily="34" charset="0"/>
-                <a:ea typeface="Cambria" pitchFamily="34" charset="-122"/>
-                <a:cs typeface="Cambria" pitchFamily="34" charset="-120"/>
+                <a:latin typeface="Helvetica" pitchFamily="34" charset="0"/>
+                <a:ea typeface="Helvetica" pitchFamily="34" charset="-122"/>
+                <a:cs typeface="Helvetica" pitchFamily="34" charset="-120"/>
               </a:rPr>
               <a:t>Agree the role and terms</a:t>
             </a:r>
@@ -11596,9 +11596,9 @@
                 <a:solidFill>
                   <a:schemeClr val="tx1"/>
                 </a:solidFill>
-                <a:latin typeface="Cambria" pitchFamily="34" charset="0"/>
-                <a:ea typeface="Cambria" pitchFamily="34" charset="-122"/>
-                <a:cs typeface="Cambria" pitchFamily="34" charset="-120"/>
+                <a:latin typeface="Helvetica" pitchFamily="34" charset="0"/>
+                <a:ea typeface="Helvetica" pitchFamily="34" charset="-122"/>
+                <a:cs typeface="Helvetica" pitchFamily="34" charset="-120"/>
               </a:rPr>
               <a:t>Choose one market and list 10 people to introduce</a:t>
             </a:r>
@@ -11696,9 +11696,9 @@
                 <a:solidFill>
                   <a:schemeClr val="tx1"/>
                 </a:solidFill>
-                <a:latin typeface="Cambria" pitchFamily="34" charset="0"/>
-                <a:ea typeface="Cambria" pitchFamily="34" charset="-122"/>
-                <a:cs typeface="Cambria" pitchFamily="34" charset="-120"/>
+                <a:latin typeface="Helvetica" pitchFamily="34" charset="0"/>
+                <a:ea typeface="Helvetica" pitchFamily="34" charset="-122"/>
+                <a:cs typeface="Helvetica" pitchFamily="34" charset="-120"/>
               </a:rPr>
               <a:t>First introductions and calls</a:t>
             </a:r>
@@ -11796,9 +11796,9 @@
                 <a:solidFill>
                   <a:schemeClr val="tx1"/>
                 </a:solidFill>
-                <a:latin typeface="Cambria" pitchFamily="34" charset="0"/>
-                <a:ea typeface="Cambria" pitchFamily="34" charset="-122"/>
-                <a:cs typeface="Cambria" pitchFamily="34" charset="-120"/>
+                <a:latin typeface="Helvetica" pitchFamily="34" charset="0"/>
+                <a:ea typeface="Helvetica" pitchFamily="34" charset="-122"/>
+                <a:cs typeface="Helvetica" pitchFamily="34" charset="-120"/>
               </a:rPr>
               <a:t>First new client, then review</a:t>
             </a:r>
@@ -12008,9 +12008,9 @@
                 <a:solidFill>
                   <a:schemeClr val="bg2"/>
                 </a:solidFill>
-                <a:latin typeface="Cambria" pitchFamily="34" charset="0"/>
-                <a:ea typeface="Cambria" pitchFamily="34" charset="-122"/>
-                <a:cs typeface="Cambria" pitchFamily="34" charset="-120"/>
+                <a:latin typeface="Helvetica" pitchFamily="34" charset="0"/>
+                <a:ea typeface="Helvetica" pitchFamily="34" charset="-122"/>
+                <a:cs typeface="Helvetica" pitchFamily="34" charset="-120"/>
               </a:rPr>
               <a:t>You know the people.</a:t>
             </a:r>
@@ -12025,9 +12025,9 @@
                 <a:solidFill>
                   <a:schemeClr val="bg2"/>
                 </a:solidFill>
-                <a:latin typeface="Cambria" pitchFamily="34" charset="0"/>
-                <a:ea typeface="Cambria" pitchFamily="34" charset="-122"/>
-                <a:cs typeface="Cambria" pitchFamily="34" charset="-120"/>
+                <a:latin typeface="Helvetica" pitchFamily="34" charset="0"/>
+                <a:ea typeface="Helvetica" pitchFamily="34" charset="-122"/>
+                <a:cs typeface="Helvetica" pitchFamily="34" charset="-120"/>
               </a:rPr>
               <a:t>We build the system.</a:t>
             </a:r>
@@ -12167,9 +12167,9 @@
                 <a:solidFill>
                   <a:schemeClr val="accent3"/>
                 </a:solidFill>
-                <a:latin typeface="Cambria" pitchFamily="34" charset="0"/>
-                <a:ea typeface="Cambria" pitchFamily="34" charset="-122"/>
-                <a:cs typeface="Cambria" pitchFamily="34" charset="-120"/>
+                <a:latin typeface="Helvetica" pitchFamily="34" charset="0"/>
+                <a:ea typeface="Helvetica" pitchFamily="34" charset="-122"/>
+                <a:cs typeface="Helvetica" pitchFamily="34" charset="-120"/>
               </a:rPr>
               <a:t>01</a:t>
             </a:r>
@@ -12208,9 +12208,9 @@
                 <a:solidFill>
                   <a:schemeClr val="bg2"/>
                 </a:solidFill>
-                <a:latin typeface="Cambria" pitchFamily="34" charset="0"/>
-                <a:ea typeface="Cambria" pitchFamily="34" charset="-122"/>
-                <a:cs typeface="Cambria" pitchFamily="34" charset="-120"/>
+                <a:latin typeface="Helvetica" pitchFamily="34" charset="0"/>
+                <a:ea typeface="Helvetica" pitchFamily="34" charset="-122"/>
+                <a:cs typeface="Helvetica" pitchFamily="34" charset="-120"/>
               </a:rPr>
               <a:t>Who we are</a:t>
             </a:r>
@@ -12395,9 +12395,9 @@
                 <a:solidFill>
                   <a:schemeClr val="tx1"/>
                 </a:solidFill>
-                <a:latin typeface="Cambria" pitchFamily="34" charset="0"/>
-                <a:ea typeface="Cambria" pitchFamily="34" charset="-122"/>
-                <a:cs typeface="Cambria" pitchFamily="34" charset="-120"/>
+                <a:latin typeface="Helvetica" pitchFamily="34" charset="0"/>
+                <a:ea typeface="Helvetica" pitchFamily="34" charset="-122"/>
+                <a:cs typeface="Helvetica" pitchFamily="34" charset="-120"/>
               </a:rPr>
               <a:t>We help experts win clients, without using their time</a:t>
             </a:r>
@@ -12510,9 +12510,9 @@
                 <a:solidFill>
                   <a:schemeClr val="tx1"/>
                 </a:solidFill>
-                <a:latin typeface="Cambria" pitchFamily="34" charset="0"/>
-                <a:ea typeface="Cambria" pitchFamily="34" charset="-122"/>
-                <a:cs typeface="Cambria" pitchFamily="34" charset="-120"/>
+                <a:latin typeface="Helvetica" pitchFamily="34" charset="0"/>
+                <a:ea typeface="Helvetica" pitchFamily="34" charset="-122"/>
+                <a:cs typeface="Helvetica" pitchFamily="34" charset="-120"/>
               </a:rPr>
               <a:t>What we do</a:t>
             </a:r>
@@ -12661,9 +12661,9 @@
                 <a:solidFill>
                   <a:schemeClr val="tx1"/>
                 </a:solidFill>
-                <a:latin typeface="Cambria" pitchFamily="34" charset="0"/>
-                <a:ea typeface="Cambria" pitchFamily="34" charset="-122"/>
-                <a:cs typeface="Cambria" pitchFamily="34" charset="-120"/>
+                <a:latin typeface="Helvetica" pitchFamily="34" charset="0"/>
+                <a:ea typeface="Helvetica" pitchFamily="34" charset="-122"/>
+                <a:cs typeface="Helvetica" pitchFamily="34" charset="-120"/>
               </a:rPr>
               <a:t>Who we are</a:t>
             </a:r>
@@ -12826,9 +12826,9 @@
                 <a:solidFill>
                   <a:schemeClr val="tx1"/>
                 </a:solidFill>
-                <a:latin typeface="Cambria" pitchFamily="34" charset="0"/>
-                <a:ea typeface="Cambria" pitchFamily="34" charset="-122"/>
-                <a:cs typeface="Cambria" pitchFamily="34" charset="-120"/>
+                <a:latin typeface="Helvetica" pitchFamily="34" charset="0"/>
+                <a:ea typeface="Helvetica" pitchFamily="34" charset="-122"/>
+                <a:cs typeface="Helvetica" pitchFamily="34" charset="-120"/>
               </a:rPr>
               <a:t>How we work</a:t>
             </a:r>
@@ -13011,9 +13011,9 @@
                 <a:solidFill>
                   <a:schemeClr val="tx1"/>
                 </a:solidFill>
-                <a:latin typeface="Cambria" pitchFamily="34" charset="0"/>
-                <a:ea typeface="Cambria" pitchFamily="34" charset="-122"/>
-                <a:cs typeface="Cambria" pitchFamily="34" charset="-120"/>
+                <a:latin typeface="Helvetica" pitchFamily="34" charset="0"/>
+                <a:ea typeface="Helvetica" pitchFamily="34" charset="-122"/>
+                <a:cs typeface="Helvetica" pitchFamily="34" charset="-120"/>
               </a:rPr>
               <a:t>The problem: buyers don’t know great experts exist</a:t>
             </a:r>
@@ -13126,9 +13126,9 @@
                 <a:solidFill>
                   <a:schemeClr val="tx1"/>
                 </a:solidFill>
-                <a:latin typeface="Cambria" pitchFamily="34" charset="0"/>
-                <a:ea typeface="Cambria" pitchFamily="34" charset="-122"/>
-                <a:cs typeface="Cambria" pitchFamily="34" charset="-120"/>
+                <a:latin typeface="Helvetica" pitchFamily="34" charset="0"/>
+                <a:ea typeface="Helvetica" pitchFamily="34" charset="-122"/>
+                <a:cs typeface="Helvetica" pitchFamily="34" charset="-120"/>
               </a:rPr>
               <a:t>No time</a:t>
             </a:r>
@@ -13277,9 +13277,9 @@
                 <a:solidFill>
                   <a:schemeClr val="tx1"/>
                 </a:solidFill>
-                <a:latin typeface="Cambria" pitchFamily="34" charset="0"/>
-                <a:ea typeface="Cambria" pitchFamily="34" charset="-122"/>
-                <a:cs typeface="Cambria" pitchFamily="34" charset="-120"/>
+                <a:latin typeface="Helvetica" pitchFamily="34" charset="0"/>
+                <a:ea typeface="Helvetica" pitchFamily="34" charset="-122"/>
+                <a:cs typeface="Helvetica" pitchFamily="34" charset="-120"/>
               </a:rPr>
               <a:t>No system</a:t>
             </a:r>
@@ -13428,9 +13428,9 @@
                 <a:solidFill>
                   <a:schemeClr val="tx1"/>
                 </a:solidFill>
-                <a:latin typeface="Cambria" pitchFamily="34" charset="0"/>
-                <a:ea typeface="Cambria" pitchFamily="34" charset="-122"/>
-                <a:cs typeface="Cambria" pitchFamily="34" charset="-120"/>
+                <a:latin typeface="Helvetica" pitchFamily="34" charset="0"/>
+                <a:ea typeface="Helvetica" pitchFamily="34" charset="-122"/>
+                <a:cs typeface="Helvetica" pitchFamily="34" charset="-120"/>
               </a:rPr>
               <a:t>Too much noise</a:t>
             </a:r>
@@ -13649,9 +13649,9 @@
                 <a:solidFill>
                   <a:schemeClr val="tx1"/>
                 </a:solidFill>
-                <a:latin typeface="Cambria" pitchFamily="34" charset="0"/>
-                <a:ea typeface="Cambria" pitchFamily="34" charset="-122"/>
-                <a:cs typeface="Cambria" pitchFamily="34" charset="-120"/>
+                <a:latin typeface="Helvetica" pitchFamily="34" charset="0"/>
+                <a:ea typeface="Helvetica" pitchFamily="34" charset="-122"/>
+                <a:cs typeface="Helvetica" pitchFamily="34" charset="-120"/>
               </a:rPr>
               <a:t>The audit shows it: real stories get 6× more attention</a:t>
             </a:r>
@@ -13828,9 +13828,9 @@
                 <a:solidFill>
                   <a:schemeClr val="accent3"/>
                 </a:solidFill>
-                <a:latin typeface="Cambria" pitchFamily="34" charset="0"/>
-                <a:ea typeface="Cambria" pitchFamily="34" charset="-122"/>
-                <a:cs typeface="Cambria" pitchFamily="34" charset="-120"/>
+                <a:latin typeface="Helvetica" pitchFamily="34" charset="0"/>
+                <a:ea typeface="Helvetica" pitchFamily="34" charset="-122"/>
+                <a:cs typeface="Helvetica" pitchFamily="34" charset="-120"/>
               </a:rPr>
               <a:t>02</a:t>
             </a:r>
@@ -13869,9 +13869,9 @@
                 <a:solidFill>
                   <a:schemeClr val="bg2"/>
                 </a:solidFill>
-                <a:latin typeface="Cambria" pitchFamily="34" charset="0"/>
-                <a:ea typeface="Cambria" pitchFamily="34" charset="-122"/>
-                <a:cs typeface="Cambria" pitchFamily="34" charset="-120"/>
+                <a:latin typeface="Helvetica" pitchFamily="34" charset="0"/>
+                <a:ea typeface="Helvetica" pitchFamily="34" charset="-122"/>
+                <a:cs typeface="Helvetica" pitchFamily="34" charset="-120"/>
               </a:rPr>
               <a:t>What we’ve done</a:t>
             </a:r>
@@ -14056,9 +14056,9 @@
                 <a:solidFill>
                   <a:schemeClr val="tx1"/>
                 </a:solidFill>
-                <a:latin typeface="Cambria" pitchFamily="34" charset="0"/>
-                <a:ea typeface="Cambria" pitchFamily="34" charset="-122"/>
-                <a:cs typeface="Cambria" pitchFamily="34" charset="-120"/>
+                <a:latin typeface="Helvetica" pitchFamily="34" charset="0"/>
+                <a:ea typeface="Helvetica" pitchFamily="34" charset="-122"/>
+                <a:cs typeface="Helvetica" pitchFamily="34" charset="-120"/>
               </a:rPr>
               <a:t>Three clients, three different markets, one method</a:t>
             </a:r>
@@ -14107,16 +14107,16 @@
                           <a:solidFill>
                             <a:schemeClr val="bg1"/>
                           </a:solidFill>
-                          <a:latin typeface="Cambria" pitchFamily="34" charset="0"/>
-                          <a:ea typeface="Cambria" pitchFamily="34" charset="-122"/>
-                          <a:cs typeface="Cambria" pitchFamily="34" charset="-120"/>
+                          <a:latin typeface="Helvetica" pitchFamily="34" charset="0"/>
+                          <a:ea typeface="Helvetica" pitchFamily="34" charset="-122"/>
+                          <a:cs typeface="Helvetica" pitchFamily="34" charset="-120"/>
                         </a:rPr>
                         <a:t>Client</a:t>
                       </a:r>
                       <a:endParaRPr lang="en-US" sz="1600" dirty="0">
-                        <a:latin typeface="Cambria" charset="0"/>
-                        <a:ea typeface="Cambria" charset="0"/>
-                        <a:cs typeface="Cambria" charset="0"/>
+                        <a:latin typeface="Helvetica" charset="0"/>
+                        <a:ea typeface="Helvetica" charset="0"/>
+                        <a:cs typeface="Helvetica" charset="0"/>
                       </a:endParaRPr>
                     </a:p>
                   </a:txBody>
@@ -14175,16 +14175,16 @@
                           <a:solidFill>
                             <a:schemeClr val="bg1"/>
                           </a:solidFill>
-                          <a:latin typeface="Cambria" pitchFamily="34" charset="0"/>
-                          <a:ea typeface="Cambria" pitchFamily="34" charset="-122"/>
-                          <a:cs typeface="Cambria" pitchFamily="34" charset="-120"/>
+                          <a:latin typeface="Helvetica" pitchFamily="34" charset="0"/>
+                          <a:ea typeface="Helvetica" pitchFamily="34" charset="-122"/>
+                          <a:cs typeface="Helvetica" pitchFamily="34" charset="-120"/>
                         </a:rPr>
                         <a:t>What they sell</a:t>
                       </a:r>
                       <a:endParaRPr lang="en-US" sz="1600" dirty="0">
-                        <a:latin typeface="Cambria" charset="0"/>
-                        <a:ea typeface="Cambria" charset="0"/>
-                        <a:cs typeface="Cambria" charset="0"/>
+                        <a:latin typeface="Helvetica" charset="0"/>
+                        <a:ea typeface="Helvetica" charset="0"/>
+                        <a:cs typeface="Helvetica" charset="0"/>
                       </a:endParaRPr>
                     </a:p>
                   </a:txBody>
@@ -14243,16 +14243,16 @@
                           <a:solidFill>
                             <a:schemeClr val="bg1"/>
                           </a:solidFill>
-                          <a:latin typeface="Cambria" pitchFamily="34" charset="0"/>
-                          <a:ea typeface="Cambria" pitchFamily="34" charset="-122"/>
-                          <a:cs typeface="Cambria" pitchFamily="34" charset="-120"/>
+                          <a:latin typeface="Helvetica" pitchFamily="34" charset="0"/>
+                          <a:ea typeface="Helvetica" pitchFamily="34" charset="-122"/>
+                          <a:cs typeface="Helvetica" pitchFamily="34" charset="-120"/>
                         </a:rPr>
                         <a:t>What we did</a:t>
                       </a:r>
                       <a:endParaRPr lang="en-US" sz="1600" dirty="0">
-                        <a:latin typeface="Cambria" charset="0"/>
-                        <a:ea typeface="Cambria" charset="0"/>
-                        <a:cs typeface="Cambria" charset="0"/>
+                        <a:latin typeface="Helvetica" charset="0"/>
+                        <a:ea typeface="Helvetica" charset="0"/>
+                        <a:cs typeface="Helvetica" charset="0"/>
                       </a:endParaRPr>
                     </a:p>
                   </a:txBody>
@@ -15022,9 +15022,9 @@
                 <a:solidFill>
                   <a:schemeClr val="accent3"/>
                 </a:solidFill>
-                <a:latin typeface="Cambria" pitchFamily="34" charset="0"/>
-                <a:ea typeface="Cambria" pitchFamily="34" charset="-122"/>
-                <a:cs typeface="Cambria" pitchFamily="34" charset="-120"/>
+                <a:latin typeface="Helvetica" pitchFamily="34" charset="0"/>
+                <a:ea typeface="Helvetica" pitchFamily="34" charset="-122"/>
+                <a:cs typeface="Helvetica" pitchFamily="34" charset="-120"/>
               </a:rPr>
               <a:t>03</a:t>
             </a:r>
@@ -15063,9 +15063,9 @@
                 <a:solidFill>
                   <a:schemeClr val="bg2"/>
                 </a:solidFill>
-                <a:latin typeface="Cambria" pitchFamily="34" charset="0"/>
-                <a:ea typeface="Cambria" pitchFamily="34" charset="-122"/>
-                <a:cs typeface="Cambria" pitchFamily="34" charset="-120"/>
+                <a:latin typeface="Helvetica" pitchFamily="34" charset="0"/>
+                <a:ea typeface="Helvetica" pitchFamily="34" charset="-122"/>
+                <a:cs typeface="Helvetica" pitchFamily="34" charset="-120"/>
               </a:rPr>
               <a:t>What we offer</a:t>
             </a:r>
@@ -15207,7 +15207,7 @@
     </a:clrScheme>
     <a:fontScheme name="Extol Affiliates">
       <a:majorFont>
-        <a:latin typeface="Cambria"/>
+        <a:latin typeface="Helvetica"/>
         <a:ea typeface=""/>
         <a:cs typeface=""/>
         <a:font script="Jpan" typeface="游ゴシック Light"/>
@@ -15259,7 +15259,7 @@
         <a:font script="Tfng" typeface="Ebrima"/>
       </a:majorFont>
       <a:minorFont>
-        <a:latin typeface="Calibri"/>
+        <a:latin typeface="Helvetica"/>
         <a:ea typeface=""/>
         <a:cs typeface=""/>
         <a:font script="Jpan" typeface="游ゴシック"/>

</xml_diff>